<commit_message>
Added onboarding and github
* added git-github/
* added onboarding-offboarding/

Need to put the pdfs online. Can leave the pptx in repo
</commit_message>
<xml_diff>
--- a/onboarding-offboarding/Onboarding_Offboarding_Fall2025.pptx
+++ b/onboarding-offboarding/Onboarding_Offboarding_Fall2025.pptx
@@ -298,7 +298,7 @@
             <a:fld id="{48A87A34-81AB-432B-8DAE-1953F412C126}" type="datetimeFigureOut">
               <a:rPr lang="en-US" dirty="0"/>
               <a:pPr/>
-              <a:t>8/25/25</a:t>
+              <a:t>9/24/25</a:t>
             </a:fld>
             <a:endParaRPr lang="en-US" dirty="0"/>
           </a:p>
@@ -441,6 +441,13 @@
               <a:tailEnd/>
             </a:ln>
           </p:spPr>
+          <p:txBody>
+            <a:bodyPr/>
+            <a:lstStyle/>
+            <a:p>
+              <a:endParaRPr lang="en-US"/>
+            </a:p>
+          </p:txBody>
         </p:sp>
         <p:sp>
           <p:nvSpPr>
@@ -499,6 +506,13 @@
               <a:tailEnd/>
             </a:ln>
           </p:spPr>
+          <p:txBody>
+            <a:bodyPr/>
+            <a:lstStyle/>
+            <a:p>
+              <a:endParaRPr lang="en-US"/>
+            </a:p>
+          </p:txBody>
         </p:sp>
       </p:grpSp>
     </p:spTree>
@@ -626,7 +640,7 @@
           <a:p>
             <a:fld id="{48A87A34-81AB-432B-8DAE-1953F412C126}" type="datetimeFigureOut">
               <a:rPr lang="en-US" dirty="0"/>
-              <a:t>8/25/25</a:t>
+              <a:t>9/24/25</a:t>
             </a:fld>
             <a:endParaRPr lang="en-US" dirty="0"/>
           </a:p>
@@ -804,7 +818,7 @@
           <a:p>
             <a:fld id="{48A87A34-81AB-432B-8DAE-1953F412C126}" type="datetimeFigureOut">
               <a:rPr lang="en-US" dirty="0"/>
-              <a:t>8/25/25</a:t>
+              <a:t>9/24/25</a:t>
             </a:fld>
             <a:endParaRPr lang="en-US" dirty="0"/>
           </a:p>
@@ -972,7 +986,7 @@
           <a:p>
             <a:fld id="{48A87A34-81AB-432B-8DAE-1953F412C126}" type="datetimeFigureOut">
               <a:rPr lang="en-US" dirty="0"/>
-              <a:t>8/25/25</a:t>
+              <a:t>9/24/25</a:t>
             </a:fld>
             <a:endParaRPr lang="en-US" dirty="0"/>
           </a:p>
@@ -1248,7 +1262,7 @@
           <a:p>
             <a:fld id="{48A87A34-81AB-432B-8DAE-1953F412C126}" type="datetimeFigureOut">
               <a:rPr lang="en-US" dirty="0"/>
-              <a:t>8/25/25</a:t>
+              <a:t>9/24/25</a:t>
             </a:fld>
             <a:endParaRPr lang="en-US" dirty="0"/>
           </a:p>
@@ -1377,6 +1391,13 @@
             <a:tailEnd/>
           </a:ln>
         </p:spPr>
+        <p:txBody>
+          <a:bodyPr/>
+          <a:lstStyle/>
+          <a:p>
+            <a:endParaRPr lang="en-US"/>
+          </a:p>
+        </p:txBody>
       </p:sp>
     </p:spTree>
     <p:extLst>
@@ -1639,7 +1660,7 @@
           <a:p>
             <a:fld id="{48A87A34-81AB-432B-8DAE-1953F412C126}" type="datetimeFigureOut">
               <a:rPr lang="en-US" dirty="0"/>
-              <a:t>8/25/25</a:t>
+              <a:t>9/24/25</a:t>
             </a:fld>
             <a:endParaRPr lang="en-US" dirty="0"/>
           </a:p>
@@ -2114,7 +2135,7 @@
             <a:fld id="{48A87A34-81AB-432B-8DAE-1953F412C126}" type="datetimeFigureOut">
               <a:rPr lang="en-US" dirty="0"/>
               <a:pPr/>
-              <a:t>8/25/25</a:t>
+              <a:t>9/24/25</a:t>
             </a:fld>
             <a:endParaRPr lang="en-US" dirty="0"/>
           </a:p>
@@ -2232,7 +2253,7 @@
           <a:p>
             <a:fld id="{48A87A34-81AB-432B-8DAE-1953F412C126}" type="datetimeFigureOut">
               <a:rPr lang="en-US" dirty="0"/>
-              <a:t>8/25/25</a:t>
+              <a:t>9/24/25</a:t>
             </a:fld>
             <a:endParaRPr lang="en-US" dirty="0"/>
           </a:p>
@@ -2327,7 +2348,7 @@
           <a:p>
             <a:fld id="{48A87A34-81AB-432B-8DAE-1953F412C126}" type="datetimeFigureOut">
               <a:rPr lang="en-US" dirty="0"/>
-              <a:t>8/25/25</a:t>
+              <a:t>9/24/25</a:t>
             </a:fld>
             <a:endParaRPr lang="en-US" dirty="0"/>
           </a:p>
@@ -2671,7 +2692,7 @@
           <a:p>
             <a:fld id="{48A87A34-81AB-432B-8DAE-1953F412C126}" type="datetimeFigureOut">
               <a:rPr lang="en-US" dirty="0"/>
-              <a:t>8/25/25</a:t>
+              <a:t>9/24/25</a:t>
             </a:fld>
             <a:endParaRPr lang="en-US" dirty="0"/>
           </a:p>
@@ -2850,6 +2871,13 @@
             <a:schemeClr val="lt1"/>
           </a:fontRef>
         </p:style>
+        <p:txBody>
+          <a:bodyPr/>
+          <a:lstStyle/>
+          <a:p>
+            <a:endParaRPr lang="en-US"/>
+          </a:p>
+        </p:txBody>
       </p:sp>
       <p:sp>
         <p:nvSpPr>
@@ -3057,7 +3085,7 @@
           <a:p>
             <a:fld id="{48A87A34-81AB-432B-8DAE-1953F412C126}" type="datetimeFigureOut">
               <a:rPr lang="en-US" dirty="0"/>
-              <a:t>8/25/25</a:t>
+              <a:t>9/24/25</a:t>
             </a:fld>
             <a:endParaRPr lang="en-US" dirty="0"/>
           </a:p>
@@ -3168,6 +3196,13 @@
             <a:schemeClr val="lt1"/>
           </a:fontRef>
         </p:style>
+        <p:txBody>
+          <a:bodyPr/>
+          <a:lstStyle/>
+          <a:p>
+            <a:endParaRPr lang="en-US"/>
+          </a:p>
+        </p:txBody>
       </p:sp>
     </p:spTree>
     <p:extLst>
@@ -3334,7 +3369,7 @@
             <a:fld id="{48A87A34-81AB-432B-8DAE-1953F412C126}" type="datetimeFigureOut">
               <a:rPr lang="en-US" dirty="0"/>
               <a:pPr/>
-              <a:t>8/25/25</a:t>
+              <a:t>9/24/25</a:t>
             </a:fld>
             <a:endParaRPr lang="en-US" dirty="0"/>
           </a:p>
@@ -3452,6 +3487,13 @@
             <a:schemeClr val="lt1"/>
           </a:fontRef>
         </p:style>
+        <p:txBody>
+          <a:bodyPr/>
+          <a:lstStyle/>
+          <a:p>
+            <a:endParaRPr lang="en-US"/>
+          </a:p>
+        </p:txBody>
       </p:sp>
     </p:spTree>
     <p:extLst>
@@ -6725,6 +6767,24 @@
               <a:t>Go over the onboarding document template</a:t>
             </a:r>
           </a:p>
+          <a:p>
+            <a:r>
+              <a:rPr lang="en-US">
+                <a:hlinkClick r:id="rId2"/>
+              </a:rPr>
+              <a:t>Template</a:t>
+            </a:r>
+            <a:endParaRPr lang="en-US"/>
+          </a:p>
+          <a:p>
+            <a:r>
+              <a:rPr lang="en-US">
+                <a:hlinkClick r:id="rId3"/>
+              </a:rPr>
+              <a:t>Example</a:t>
+            </a:r>
+            <a:endParaRPr lang="en-US"/>
+          </a:p>
         </p:txBody>
       </p:sp>
     </p:spTree>

</xml_diff>